<commit_message>
Week 6 Day 2 Uploads
</commit_message>
<xml_diff>
--- a/Shapiro 2025 Project/Weekly Updates/Week 5 Updates.pptx
+++ b/Shapiro 2025 Project/Weekly Updates/Week 5 Updates.pptx
@@ -6965,12 +6965,110 @@
           </a:p>
         </p:txBody>
       </p:sp>
+      <p:sp>
+        <p:nvSpPr>
+          <p:cNvPr id="3" name="Rectangle 2">
+            <a:extLst>
+              <a:ext uri="{FF2B5EF4-FFF2-40B4-BE49-F238E27FC236}">
+                <a16:creationId xmlns:a16="http://schemas.microsoft.com/office/drawing/2014/main" id="{AC889C08-FE37-40A9-BD5C-12B6163647CD}"/>
+              </a:ext>
+            </a:extLst>
+          </p:cNvPr>
+          <p:cNvSpPr/>
+          <p:nvPr/>
+        </p:nvSpPr>
+        <p:spPr>
+          <a:xfrm>
+            <a:off x="1109892" y="1305655"/>
+            <a:ext cx="1872944" cy="199697"/>
+          </a:xfrm>
+          <a:prstGeom prst="rect">
+            <a:avLst/>
+          </a:prstGeom>
+        </p:spPr>
+        <p:style>
+          <a:lnRef idx="2">
+            <a:schemeClr val="accent1">
+              <a:shade val="15000"/>
+            </a:schemeClr>
+          </a:lnRef>
+          <a:fillRef idx="1">
+            <a:schemeClr val="accent1"/>
+          </a:fillRef>
+          <a:effectRef idx="0">
+            <a:schemeClr val="accent1"/>
+          </a:effectRef>
+          <a:fontRef idx="minor">
+            <a:schemeClr val="lt1"/>
+          </a:fontRef>
+        </p:style>
+        <p:txBody>
+          <a:bodyPr rtlCol="0" anchor="ctr"/>
+          <a:lstStyle/>
+          <a:p>
+            <a:pPr algn="ctr"/>
+            <a:r>
+              <a:rPr lang="en-US" dirty="0"/>
+              <a:t>Responder</a:t>
+            </a:r>
+          </a:p>
+        </p:txBody>
+      </p:sp>
+      <p:sp>
+        <p:nvSpPr>
+          <p:cNvPr id="5" name="Rectangle 4">
+            <a:extLst>
+              <a:ext uri="{FF2B5EF4-FFF2-40B4-BE49-F238E27FC236}">
+                <a16:creationId xmlns:a16="http://schemas.microsoft.com/office/drawing/2014/main" id="{B9A8DBA4-0D6F-EB44-EA7A-14A04C02F914}"/>
+              </a:ext>
+            </a:extLst>
+          </p:cNvPr>
+          <p:cNvSpPr/>
+          <p:nvPr/>
+        </p:nvSpPr>
+        <p:spPr>
+          <a:xfrm>
+            <a:off x="4856830" y="1264849"/>
+            <a:ext cx="1872944" cy="199697"/>
+          </a:xfrm>
+          <a:prstGeom prst="rect">
+            <a:avLst/>
+          </a:prstGeom>
+        </p:spPr>
+        <p:style>
+          <a:lnRef idx="2">
+            <a:schemeClr val="accent1">
+              <a:shade val="15000"/>
+            </a:schemeClr>
+          </a:lnRef>
+          <a:fillRef idx="1">
+            <a:schemeClr val="accent1"/>
+          </a:fillRef>
+          <a:effectRef idx="0">
+            <a:schemeClr val="accent1"/>
+          </a:effectRef>
+          <a:fontRef idx="minor">
+            <a:schemeClr val="lt1"/>
+          </a:fontRef>
+        </p:style>
+        <p:txBody>
+          <a:bodyPr rtlCol="0" anchor="ctr"/>
+          <a:lstStyle/>
+          <a:p>
+            <a:pPr algn="ctr"/>
+            <a:r>
+              <a:rPr lang="en-US" dirty="0"/>
+              <a:t>Non-Responder</a:t>
+            </a:r>
+          </a:p>
+        </p:txBody>
+      </p:sp>
       <p:pic>
         <p:nvPicPr>
-          <p:cNvPr id="6" name="Picture 5">
-            <a:extLst>
-              <a:ext uri="{FF2B5EF4-FFF2-40B4-BE49-F238E27FC236}">
-                <a16:creationId xmlns:a16="http://schemas.microsoft.com/office/drawing/2014/main" id="{D8FE064C-AF3B-D955-43E7-B4F586ED1F4E}"/>
+          <p:cNvPr id="9" name="Picture 8">
+            <a:extLst>
+              <a:ext uri="{FF2B5EF4-FFF2-40B4-BE49-F238E27FC236}">
+                <a16:creationId xmlns:a16="http://schemas.microsoft.com/office/drawing/2014/main" id="{992937BE-33C6-F565-54F2-9699794B27C7}"/>
               </a:ext>
             </a:extLst>
           </p:cNvPr>
@@ -6987,8 +7085,8 @@
         </p:blipFill>
         <p:spPr>
           <a:xfrm>
-            <a:off x="154848" y="1483517"/>
-            <a:ext cx="3781121" cy="4851469"/>
+            <a:off x="96892" y="1591808"/>
+            <a:ext cx="3753899" cy="4980332"/>
           </a:xfrm>
           <a:prstGeom prst="rect">
             <a:avLst/>
@@ -6997,10 +7095,10 @@
       </p:pic>
       <p:pic>
         <p:nvPicPr>
-          <p:cNvPr id="10" name="Picture 9">
-            <a:extLst>
-              <a:ext uri="{FF2B5EF4-FFF2-40B4-BE49-F238E27FC236}">
-                <a16:creationId xmlns:a16="http://schemas.microsoft.com/office/drawing/2014/main" id="{C5815AD1-E151-769D-921D-141C4D3EBF70}"/>
+          <p:cNvPr id="12" name="Picture 11">
+            <a:extLst>
+              <a:ext uri="{FF2B5EF4-FFF2-40B4-BE49-F238E27FC236}">
+                <a16:creationId xmlns:a16="http://schemas.microsoft.com/office/drawing/2014/main" id="{705790C3-6AD2-D5B5-DE26-645F396AC9B2}"/>
               </a:ext>
             </a:extLst>
           </p:cNvPr>
@@ -7017,112 +7115,14 @@
         </p:blipFill>
         <p:spPr>
           <a:xfrm>
-            <a:off x="3935969" y="1483517"/>
-            <a:ext cx="3855641" cy="4746517"/>
+            <a:off x="4024770" y="1518658"/>
+            <a:ext cx="3851681" cy="5005383"/>
           </a:xfrm>
           <a:prstGeom prst="rect">
             <a:avLst/>
           </a:prstGeom>
         </p:spPr>
       </p:pic>
-      <p:sp>
-        <p:nvSpPr>
-          <p:cNvPr id="3" name="Rectangle 2">
-            <a:extLst>
-              <a:ext uri="{FF2B5EF4-FFF2-40B4-BE49-F238E27FC236}">
-                <a16:creationId xmlns:a16="http://schemas.microsoft.com/office/drawing/2014/main" id="{AC889C08-FE37-40A9-BD5C-12B6163647CD}"/>
-              </a:ext>
-            </a:extLst>
-          </p:cNvPr>
-          <p:cNvSpPr/>
-          <p:nvPr/>
-        </p:nvSpPr>
-        <p:spPr>
-          <a:xfrm>
-            <a:off x="1109892" y="1305655"/>
-            <a:ext cx="1872944" cy="199697"/>
-          </a:xfrm>
-          <a:prstGeom prst="rect">
-            <a:avLst/>
-          </a:prstGeom>
-        </p:spPr>
-        <p:style>
-          <a:lnRef idx="2">
-            <a:schemeClr val="accent1">
-              <a:shade val="15000"/>
-            </a:schemeClr>
-          </a:lnRef>
-          <a:fillRef idx="1">
-            <a:schemeClr val="accent1"/>
-          </a:fillRef>
-          <a:effectRef idx="0">
-            <a:schemeClr val="accent1"/>
-          </a:effectRef>
-          <a:fontRef idx="minor">
-            <a:schemeClr val="lt1"/>
-          </a:fontRef>
-        </p:style>
-        <p:txBody>
-          <a:bodyPr rtlCol="0" anchor="ctr"/>
-          <a:lstStyle/>
-          <a:p>
-            <a:pPr algn="ctr"/>
-            <a:r>
-              <a:rPr lang="en-US" dirty="0"/>
-              <a:t>Responder</a:t>
-            </a:r>
-          </a:p>
-        </p:txBody>
-      </p:sp>
-      <p:sp>
-        <p:nvSpPr>
-          <p:cNvPr id="5" name="Rectangle 4">
-            <a:extLst>
-              <a:ext uri="{FF2B5EF4-FFF2-40B4-BE49-F238E27FC236}">
-                <a16:creationId xmlns:a16="http://schemas.microsoft.com/office/drawing/2014/main" id="{B9A8DBA4-0D6F-EB44-EA7A-14A04C02F914}"/>
-              </a:ext>
-            </a:extLst>
-          </p:cNvPr>
-          <p:cNvSpPr/>
-          <p:nvPr/>
-        </p:nvSpPr>
-        <p:spPr>
-          <a:xfrm>
-            <a:off x="4856830" y="1264849"/>
-            <a:ext cx="1872944" cy="199697"/>
-          </a:xfrm>
-          <a:prstGeom prst="rect">
-            <a:avLst/>
-          </a:prstGeom>
-        </p:spPr>
-        <p:style>
-          <a:lnRef idx="2">
-            <a:schemeClr val="accent1">
-              <a:shade val="15000"/>
-            </a:schemeClr>
-          </a:lnRef>
-          <a:fillRef idx="1">
-            <a:schemeClr val="accent1"/>
-          </a:fillRef>
-          <a:effectRef idx="0">
-            <a:schemeClr val="accent1"/>
-          </a:effectRef>
-          <a:fontRef idx="minor">
-            <a:schemeClr val="lt1"/>
-          </a:fontRef>
-        </p:style>
-        <p:txBody>
-          <a:bodyPr rtlCol="0" anchor="ctr"/>
-          <a:lstStyle/>
-          <a:p>
-            <a:pPr algn="ctr"/>
-            <a:r>
-              <a:rPr lang="en-US" dirty="0"/>
-              <a:t>Non-Responder</a:t>
-            </a:r>
-          </a:p>
-        </p:txBody>
-      </p:sp>
     </p:spTree>
     <p:extLst>
       <p:ext uri="{BB962C8B-B14F-4D97-AF65-F5344CB8AC3E}">
@@ -7203,7 +7203,12 @@
             <p:ph type="body" sz="quarter" idx="14"/>
           </p:nvPr>
         </p:nvSpPr>
-        <p:spPr/>
+        <p:spPr>
+          <a:xfrm>
+            <a:off x="0" y="6534055"/>
+            <a:ext cx="4294527" cy="323165"/>
+          </a:xfrm>
+        </p:spPr>
         <p:txBody>
           <a:bodyPr/>
           <a:lstStyle/>
@@ -7212,12 +7217,257 @@
           </a:p>
         </p:txBody>
       </p:sp>
+      <p:sp>
+        <p:nvSpPr>
+          <p:cNvPr id="2" name="Rectangle: Rounded Corners 1">
+            <a:extLst>
+              <a:ext uri="{FF2B5EF4-FFF2-40B4-BE49-F238E27FC236}">
+                <a16:creationId xmlns:a16="http://schemas.microsoft.com/office/drawing/2014/main" id="{C2156BEA-CDFB-AFF4-05C2-45CE490DBAAE}"/>
+              </a:ext>
+            </a:extLst>
+          </p:cNvPr>
+          <p:cNvSpPr/>
+          <p:nvPr/>
+        </p:nvSpPr>
+        <p:spPr>
+          <a:xfrm>
+            <a:off x="393285" y="2071719"/>
+            <a:ext cx="3049051" cy="353148"/>
+          </a:xfrm>
+          <a:prstGeom prst="roundRect">
+            <a:avLst/>
+          </a:prstGeom>
+        </p:spPr>
+        <p:style>
+          <a:lnRef idx="2">
+            <a:schemeClr val="accent1">
+              <a:shade val="15000"/>
+            </a:schemeClr>
+          </a:lnRef>
+          <a:fillRef idx="1">
+            <a:schemeClr val="accent1"/>
+          </a:fillRef>
+          <a:effectRef idx="0">
+            <a:schemeClr val="accent1"/>
+          </a:effectRef>
+          <a:fontRef idx="minor">
+            <a:schemeClr val="lt1"/>
+          </a:fontRef>
+        </p:style>
+        <p:txBody>
+          <a:bodyPr rtlCol="0" anchor="ctr"/>
+          <a:lstStyle/>
+          <a:p>
+            <a:pPr algn="ctr"/>
+            <a:r>
+              <a:rPr lang="en-US" dirty="0"/>
+              <a:t>Neighboring Cells</a:t>
+            </a:r>
+          </a:p>
+        </p:txBody>
+      </p:sp>
+      <p:sp>
+        <p:nvSpPr>
+          <p:cNvPr id="6" name="Rectangle: Rounded Corners 5">
+            <a:extLst>
+              <a:ext uri="{FF2B5EF4-FFF2-40B4-BE49-F238E27FC236}">
+                <a16:creationId xmlns:a16="http://schemas.microsoft.com/office/drawing/2014/main" id="{874B25B2-4820-F7F5-F320-A93BC56F49A5}"/>
+              </a:ext>
+            </a:extLst>
+          </p:cNvPr>
+          <p:cNvSpPr/>
+          <p:nvPr/>
+        </p:nvSpPr>
+        <p:spPr>
+          <a:xfrm>
+            <a:off x="4682556" y="2071719"/>
+            <a:ext cx="3219121" cy="353148"/>
+          </a:xfrm>
+          <a:prstGeom prst="roundRect">
+            <a:avLst/>
+          </a:prstGeom>
+        </p:spPr>
+        <p:style>
+          <a:lnRef idx="2">
+            <a:schemeClr val="accent1">
+              <a:shade val="15000"/>
+            </a:schemeClr>
+          </a:lnRef>
+          <a:fillRef idx="1">
+            <a:schemeClr val="accent1"/>
+          </a:fillRef>
+          <a:effectRef idx="0">
+            <a:schemeClr val="accent1"/>
+          </a:effectRef>
+          <a:fontRef idx="minor">
+            <a:schemeClr val="lt1"/>
+          </a:fontRef>
+        </p:style>
+        <p:txBody>
+          <a:bodyPr rtlCol="0" anchor="ctr"/>
+          <a:lstStyle/>
+          <a:p>
+            <a:pPr algn="ctr"/>
+            <a:r>
+              <a:rPr lang="en-US" dirty="0"/>
+              <a:t>Overall Sample Frequency</a:t>
+            </a:r>
+          </a:p>
+        </p:txBody>
+      </p:sp>
+      <p:sp>
+        <p:nvSpPr>
+          <p:cNvPr id="8" name="Rectangle 7">
+            <a:extLst>
+              <a:ext uri="{FF2B5EF4-FFF2-40B4-BE49-F238E27FC236}">
+                <a16:creationId xmlns:a16="http://schemas.microsoft.com/office/drawing/2014/main" id="{61C2C404-8ACC-B191-41CA-A27C8FCC1693}"/>
+              </a:ext>
+            </a:extLst>
+          </p:cNvPr>
+          <p:cNvSpPr/>
+          <p:nvPr/>
+        </p:nvSpPr>
+        <p:spPr>
+          <a:xfrm>
+            <a:off x="3840479" y="2117981"/>
+            <a:ext cx="384679" cy="261838"/>
+          </a:xfrm>
+          <a:prstGeom prst="rect">
+            <a:avLst/>
+          </a:prstGeom>
+        </p:spPr>
+        <p:style>
+          <a:lnRef idx="2">
+            <a:schemeClr val="accent1">
+              <a:shade val="15000"/>
+            </a:schemeClr>
+          </a:lnRef>
+          <a:fillRef idx="1">
+            <a:schemeClr val="accent1"/>
+          </a:fillRef>
+          <a:effectRef idx="0">
+            <a:schemeClr val="accent1"/>
+          </a:effectRef>
+          <a:fontRef idx="minor">
+            <a:schemeClr val="lt1"/>
+          </a:fontRef>
+        </p:style>
+        <p:txBody>
+          <a:bodyPr rtlCol="0" anchor="ctr"/>
+          <a:lstStyle/>
+          <a:p>
+            <a:pPr algn="ctr"/>
+            <a:r>
+              <a:rPr lang="en-US" dirty="0"/>
+              <a:t>-</a:t>
+            </a:r>
+          </a:p>
+        </p:txBody>
+      </p:sp>
+      <p:sp>
+        <p:nvSpPr>
+          <p:cNvPr id="9" name="Rectangle 8">
+            <a:extLst>
+              <a:ext uri="{FF2B5EF4-FFF2-40B4-BE49-F238E27FC236}">
+                <a16:creationId xmlns:a16="http://schemas.microsoft.com/office/drawing/2014/main" id="{77BF3D68-B4FB-8285-B420-1EBBFF675BDA}"/>
+              </a:ext>
+            </a:extLst>
+          </p:cNvPr>
+          <p:cNvSpPr/>
+          <p:nvPr/>
+        </p:nvSpPr>
+        <p:spPr>
+          <a:xfrm>
+            <a:off x="8166735" y="2105515"/>
+            <a:ext cx="384679" cy="261838"/>
+          </a:xfrm>
+          <a:prstGeom prst="rect">
+            <a:avLst/>
+          </a:prstGeom>
+        </p:spPr>
+        <p:style>
+          <a:lnRef idx="2">
+            <a:schemeClr val="accent1">
+              <a:shade val="15000"/>
+            </a:schemeClr>
+          </a:lnRef>
+          <a:fillRef idx="1">
+            <a:schemeClr val="accent1"/>
+          </a:fillRef>
+          <a:effectRef idx="0">
+            <a:schemeClr val="accent1"/>
+          </a:effectRef>
+          <a:fontRef idx="minor">
+            <a:schemeClr val="lt1"/>
+          </a:fontRef>
+        </p:style>
+        <p:txBody>
+          <a:bodyPr rtlCol="0" anchor="ctr"/>
+          <a:lstStyle/>
+          <a:p>
+            <a:pPr algn="ctr"/>
+            <a:r>
+              <a:rPr lang="en-US" dirty="0"/>
+              <a:t>=</a:t>
+            </a:r>
+          </a:p>
+        </p:txBody>
+      </p:sp>
+      <p:sp>
+        <p:nvSpPr>
+          <p:cNvPr id="10" name="Rectangle 9">
+            <a:extLst>
+              <a:ext uri="{FF2B5EF4-FFF2-40B4-BE49-F238E27FC236}">
+                <a16:creationId xmlns:a16="http://schemas.microsoft.com/office/drawing/2014/main" id="{60E27B0E-E635-F4C9-1C05-A322595C3FED}"/>
+              </a:ext>
+            </a:extLst>
+          </p:cNvPr>
+          <p:cNvSpPr/>
+          <p:nvPr/>
+        </p:nvSpPr>
+        <p:spPr>
+          <a:xfrm>
+            <a:off x="8949557" y="2071719"/>
+            <a:ext cx="2237654" cy="308100"/>
+          </a:xfrm>
+          <a:prstGeom prst="rect">
+            <a:avLst/>
+          </a:prstGeom>
+        </p:spPr>
+        <p:style>
+          <a:lnRef idx="2">
+            <a:schemeClr val="accent1">
+              <a:shade val="15000"/>
+            </a:schemeClr>
+          </a:lnRef>
+          <a:fillRef idx="1">
+            <a:schemeClr val="accent1"/>
+          </a:fillRef>
+          <a:effectRef idx="0">
+            <a:schemeClr val="accent1"/>
+          </a:effectRef>
+          <a:fontRef idx="minor">
+            <a:schemeClr val="lt1"/>
+          </a:fontRef>
+        </p:style>
+        <p:txBody>
+          <a:bodyPr rtlCol="0" anchor="ctr"/>
+          <a:lstStyle/>
+          <a:p>
+            <a:pPr algn="ctr"/>
+            <a:r>
+              <a:rPr lang="en-US" dirty="0"/>
+              <a:t>Delta Matrix</a:t>
+            </a:r>
+          </a:p>
+        </p:txBody>
+      </p:sp>
       <p:pic>
         <p:nvPicPr>
-          <p:cNvPr id="3" name="Picture 2">
-            <a:extLst>
-              <a:ext uri="{FF2B5EF4-FFF2-40B4-BE49-F238E27FC236}">
-                <a16:creationId xmlns:a16="http://schemas.microsoft.com/office/drawing/2014/main" id="{C0DA28DE-31CD-797A-9559-0C229A021204}"/>
+          <p:cNvPr id="16" name="Picture 15">
+            <a:extLst>
+              <a:ext uri="{FF2B5EF4-FFF2-40B4-BE49-F238E27FC236}">
+                <a16:creationId xmlns:a16="http://schemas.microsoft.com/office/drawing/2014/main" id="{FAD229C0-7859-1515-35AD-E8CBC6A76986}"/>
               </a:ext>
             </a:extLst>
           </p:cNvPr>
@@ -7228,15 +7478,15 @@
         </p:nvPicPr>
         <p:blipFill>
           <a:blip r:embed="rId3"/>
-          <a:srcRect t="10712"/>
+          <a:srcRect t="5436"/>
           <a:stretch>
             <a:fillRect/>
           </a:stretch>
         </p:blipFill>
         <p:spPr>
           <a:xfrm>
-            <a:off x="77119" y="2596609"/>
-            <a:ext cx="3865981" cy="3204345"/>
+            <a:off x="4294527" y="2735966"/>
+            <a:ext cx="4377989" cy="4043206"/>
           </a:xfrm>
           <a:prstGeom prst="rect">
             <a:avLst/>
@@ -7245,10 +7495,10 @@
       </p:pic>
       <p:pic>
         <p:nvPicPr>
-          <p:cNvPr id="5" name="Picture 4">
-            <a:extLst>
-              <a:ext uri="{FF2B5EF4-FFF2-40B4-BE49-F238E27FC236}">
-                <a16:creationId xmlns:a16="http://schemas.microsoft.com/office/drawing/2014/main" id="{0CFC4864-43E9-10C5-3886-286CA1AC3FCA}"/>
+          <p:cNvPr id="20" name="Picture 19">
+            <a:extLst>
+              <a:ext uri="{FF2B5EF4-FFF2-40B4-BE49-F238E27FC236}">
+                <a16:creationId xmlns:a16="http://schemas.microsoft.com/office/drawing/2014/main" id="{6DF9AEC9-EA93-02CA-74D1-F58317DFFC81}"/>
               </a:ext>
             </a:extLst>
           </p:cNvPr>
@@ -7259,15 +7509,14 @@
         </p:nvPicPr>
         <p:blipFill>
           <a:blip r:embed="rId4"/>
-          <a:srcRect t="10372"/>
           <a:stretch>
             <a:fillRect/>
           </a:stretch>
         </p:blipFill>
         <p:spPr>
           <a:xfrm>
-            <a:off x="4460516" y="2505038"/>
-            <a:ext cx="4063570" cy="3295916"/>
+            <a:off x="328268" y="2524788"/>
+            <a:ext cx="3663562" cy="3273732"/>
           </a:xfrm>
           <a:prstGeom prst="rect">
             <a:avLst/>
@@ -7276,249 +7525,91 @@
       </p:pic>
       <p:sp>
         <p:nvSpPr>
-          <p:cNvPr id="2" name="Rectangle: Rounded Corners 1">
-            <a:extLst>
-              <a:ext uri="{FF2B5EF4-FFF2-40B4-BE49-F238E27FC236}">
-                <a16:creationId xmlns:a16="http://schemas.microsoft.com/office/drawing/2014/main" id="{C2156BEA-CDFB-AFF4-05C2-45CE490DBAAE}"/>
-              </a:ext>
-            </a:extLst>
-          </p:cNvPr>
-          <p:cNvSpPr/>
+          <p:cNvPr id="21" name="TextBox 20">
+            <a:extLst>
+              <a:ext uri="{FF2B5EF4-FFF2-40B4-BE49-F238E27FC236}">
+                <a16:creationId xmlns:a16="http://schemas.microsoft.com/office/drawing/2014/main" id="{11A253B1-55D8-EEAE-6BC5-2C2587A8A735}"/>
+              </a:ext>
+            </a:extLst>
+          </p:cNvPr>
+          <p:cNvSpPr txBox="1"/>
           <p:nvPr/>
         </p:nvSpPr>
         <p:spPr>
           <a:xfrm>
-            <a:off x="393285" y="2071719"/>
-            <a:ext cx="3049051" cy="353148"/>
-          </a:xfrm>
-          <a:prstGeom prst="roundRect">
-            <a:avLst/>
-          </a:prstGeom>
-        </p:spPr>
-        <p:style>
-          <a:lnRef idx="2">
-            <a:schemeClr val="accent1">
-              <a:shade val="15000"/>
-            </a:schemeClr>
-          </a:lnRef>
-          <a:fillRef idx="1">
-            <a:schemeClr val="accent1"/>
-          </a:fillRef>
-          <a:effectRef idx="0">
-            <a:schemeClr val="accent1"/>
-          </a:effectRef>
-          <a:fontRef idx="minor">
-            <a:schemeClr val="lt1"/>
-          </a:fontRef>
-        </p:style>
-        <p:txBody>
-          <a:bodyPr rtlCol="0" anchor="ctr"/>
+            <a:off x="9005263" y="2735966"/>
+            <a:ext cx="2011680" cy="1477328"/>
+          </a:xfrm>
+          <a:prstGeom prst="rect">
+            <a:avLst/>
+          </a:prstGeom>
+          <a:noFill/>
+        </p:spPr>
+        <p:txBody>
+          <a:bodyPr wrap="square" rtlCol="0">
+            <a:spAutoFit/>
+          </a:bodyPr>
           <a:lstStyle/>
           <a:p>
-            <a:pPr algn="ctr"/>
             <a:r>
               <a:rPr lang="en-US" dirty="0"/>
-              <a:t>Neighboring Cells</a:t>
-            </a:r>
-          </a:p>
-        </p:txBody>
-      </p:sp>
-      <p:sp>
-        <p:nvSpPr>
-          <p:cNvPr id="6" name="Rectangle: Rounded Corners 5">
-            <a:extLst>
-              <a:ext uri="{FF2B5EF4-FFF2-40B4-BE49-F238E27FC236}">
-                <a16:creationId xmlns:a16="http://schemas.microsoft.com/office/drawing/2014/main" id="{874B25B2-4820-F7F5-F320-A93BC56F49A5}"/>
-              </a:ext>
-            </a:extLst>
-          </p:cNvPr>
-          <p:cNvSpPr/>
+              <a:t>PMN = 24.9 – 0.96 =24.16%</a:t>
+            </a:r>
+          </a:p>
+          <a:p>
+            <a:r>
+              <a:rPr lang="en-US" dirty="0"/>
+              <a:t>Tumor=-19.4%</a:t>
+            </a:r>
+          </a:p>
+          <a:p>
+            <a:r>
+              <a:rPr lang="en-US" dirty="0"/>
+              <a:t>Endo= - 8.1%</a:t>
+            </a:r>
+          </a:p>
+          <a:p>
+            <a:r>
+              <a:rPr lang="en-US" dirty="0" err="1"/>
+              <a:t>Etc</a:t>
+            </a:r>
+            <a:r>
+              <a:rPr lang="en-US" dirty="0"/>
+              <a:t>…..</a:t>
+            </a:r>
+          </a:p>
+        </p:txBody>
+      </p:sp>
+      <p:pic>
+        <p:nvPicPr>
+          <p:cNvPr id="25" name="Picture 24">
+            <a:extLst>
+              <a:ext uri="{FF2B5EF4-FFF2-40B4-BE49-F238E27FC236}">
+                <a16:creationId xmlns:a16="http://schemas.microsoft.com/office/drawing/2014/main" id="{BAB72F9D-4869-90B0-9AA1-3E5F25307E35}"/>
+              </a:ext>
+            </a:extLst>
+          </p:cNvPr>
+          <p:cNvPicPr>
+            <a:picLocks noChangeAspect="1"/>
+          </p:cNvPicPr>
           <p:nvPr/>
-        </p:nvSpPr>
-        <p:spPr>
-          <a:xfrm>
-            <a:off x="4682556" y="2071719"/>
-            <a:ext cx="3219121" cy="353148"/>
-          </a:xfrm>
-          <a:prstGeom prst="roundRect">
-            <a:avLst/>
-          </a:prstGeom>
-        </p:spPr>
-        <p:style>
-          <a:lnRef idx="2">
-            <a:schemeClr val="accent1">
-              <a:shade val="15000"/>
-            </a:schemeClr>
-          </a:lnRef>
-          <a:fillRef idx="1">
-            <a:schemeClr val="accent1"/>
-          </a:fillRef>
-          <a:effectRef idx="0">
-            <a:schemeClr val="accent1"/>
-          </a:effectRef>
-          <a:fontRef idx="minor">
-            <a:schemeClr val="lt1"/>
-          </a:fontRef>
-        </p:style>
-        <p:txBody>
-          <a:bodyPr rtlCol="0" anchor="ctr"/>
-          <a:lstStyle/>
-          <a:p>
-            <a:pPr algn="ctr"/>
-            <a:r>
-              <a:rPr lang="en-US" dirty="0"/>
-              <a:t>Overall Sample Frequency</a:t>
-            </a:r>
-          </a:p>
-        </p:txBody>
-      </p:sp>
-      <p:sp>
-        <p:nvSpPr>
-          <p:cNvPr id="8" name="Rectangle 7">
-            <a:extLst>
-              <a:ext uri="{FF2B5EF4-FFF2-40B4-BE49-F238E27FC236}">
-                <a16:creationId xmlns:a16="http://schemas.microsoft.com/office/drawing/2014/main" id="{61C2C404-8ACC-B191-41CA-A27C8FCC1693}"/>
-              </a:ext>
-            </a:extLst>
-          </p:cNvPr>
-          <p:cNvSpPr/>
-          <p:nvPr/>
-        </p:nvSpPr>
-        <p:spPr>
-          <a:xfrm>
-            <a:off x="3840479" y="2117981"/>
-            <a:ext cx="384679" cy="261838"/>
+        </p:nvPicPr>
+        <p:blipFill>
+          <a:blip r:embed="rId5"/>
+          <a:stretch>
+            <a:fillRect/>
+          </a:stretch>
+        </p:blipFill>
+        <p:spPr>
+          <a:xfrm>
+            <a:off x="7289974" y="6557602"/>
+            <a:ext cx="4207225" cy="221570"/>
           </a:xfrm>
           <a:prstGeom prst="rect">
             <a:avLst/>
           </a:prstGeom>
         </p:spPr>
-        <p:style>
-          <a:lnRef idx="2">
-            <a:schemeClr val="accent1">
-              <a:shade val="15000"/>
-            </a:schemeClr>
-          </a:lnRef>
-          <a:fillRef idx="1">
-            <a:schemeClr val="accent1"/>
-          </a:fillRef>
-          <a:effectRef idx="0">
-            <a:schemeClr val="accent1"/>
-          </a:effectRef>
-          <a:fontRef idx="minor">
-            <a:schemeClr val="lt1"/>
-          </a:fontRef>
-        </p:style>
-        <p:txBody>
-          <a:bodyPr rtlCol="0" anchor="ctr"/>
-          <a:lstStyle/>
-          <a:p>
-            <a:pPr algn="ctr"/>
-            <a:r>
-              <a:rPr lang="en-US" dirty="0"/>
-              <a:t>-</a:t>
-            </a:r>
-          </a:p>
-        </p:txBody>
-      </p:sp>
-      <p:sp>
-        <p:nvSpPr>
-          <p:cNvPr id="9" name="Rectangle 8">
-            <a:extLst>
-              <a:ext uri="{FF2B5EF4-FFF2-40B4-BE49-F238E27FC236}">
-                <a16:creationId xmlns:a16="http://schemas.microsoft.com/office/drawing/2014/main" id="{77BF3D68-B4FB-8285-B420-1EBBFF675BDA}"/>
-              </a:ext>
-            </a:extLst>
-          </p:cNvPr>
-          <p:cNvSpPr/>
-          <p:nvPr/>
-        </p:nvSpPr>
-        <p:spPr>
-          <a:xfrm>
-            <a:off x="8166735" y="2105515"/>
-            <a:ext cx="384679" cy="261838"/>
-          </a:xfrm>
-          <a:prstGeom prst="rect">
-            <a:avLst/>
-          </a:prstGeom>
-        </p:spPr>
-        <p:style>
-          <a:lnRef idx="2">
-            <a:schemeClr val="accent1">
-              <a:shade val="15000"/>
-            </a:schemeClr>
-          </a:lnRef>
-          <a:fillRef idx="1">
-            <a:schemeClr val="accent1"/>
-          </a:fillRef>
-          <a:effectRef idx="0">
-            <a:schemeClr val="accent1"/>
-          </a:effectRef>
-          <a:fontRef idx="minor">
-            <a:schemeClr val="lt1"/>
-          </a:fontRef>
-        </p:style>
-        <p:txBody>
-          <a:bodyPr rtlCol="0" anchor="ctr"/>
-          <a:lstStyle/>
-          <a:p>
-            <a:pPr algn="ctr"/>
-            <a:r>
-              <a:rPr lang="en-US" dirty="0"/>
-              <a:t>=</a:t>
-            </a:r>
-          </a:p>
-        </p:txBody>
-      </p:sp>
-      <p:sp>
-        <p:nvSpPr>
-          <p:cNvPr id="10" name="Rectangle 9">
-            <a:extLst>
-              <a:ext uri="{FF2B5EF4-FFF2-40B4-BE49-F238E27FC236}">
-                <a16:creationId xmlns:a16="http://schemas.microsoft.com/office/drawing/2014/main" id="{60E27B0E-E635-F4C9-1C05-A322595C3FED}"/>
-              </a:ext>
-            </a:extLst>
-          </p:cNvPr>
-          <p:cNvSpPr/>
-          <p:nvPr/>
-        </p:nvSpPr>
-        <p:spPr>
-          <a:xfrm>
-            <a:off x="8949557" y="2071719"/>
-            <a:ext cx="2237654" cy="308100"/>
-          </a:xfrm>
-          <a:prstGeom prst="rect">
-            <a:avLst/>
-          </a:prstGeom>
-        </p:spPr>
-        <p:style>
-          <a:lnRef idx="2">
-            <a:schemeClr val="accent1">
-              <a:shade val="15000"/>
-            </a:schemeClr>
-          </a:lnRef>
-          <a:fillRef idx="1">
-            <a:schemeClr val="accent1"/>
-          </a:fillRef>
-          <a:effectRef idx="0">
-            <a:schemeClr val="accent1"/>
-          </a:effectRef>
-          <a:fontRef idx="minor">
-            <a:schemeClr val="lt1"/>
-          </a:fontRef>
-        </p:style>
-        <p:txBody>
-          <a:bodyPr rtlCol="0" anchor="ctr"/>
-          <a:lstStyle/>
-          <a:p>
-            <a:pPr algn="ctr"/>
-            <a:r>
-              <a:rPr lang="en-US" dirty="0"/>
-              <a:t>Delta Matrix</a:t>
-            </a:r>
-          </a:p>
-        </p:txBody>
-      </p:sp>
+      </p:pic>
     </p:spTree>
     <p:extLst>
       <p:ext uri="{BB962C8B-B14F-4D97-AF65-F5344CB8AC3E}">

</xml_diff>